<commit_message>
Deck recalé sur l'étude de marché (doc 14)
- Slide 5 : retrait du stat 'x2 à 4' (non transposable à ce site),
  remplacé par 'la puissance est le 1er critère de choix'. Ajout de
  Hadès Patrimoine comme preuve que le métier existe en France.
- Slide 9 : séquence inversée — Étape 1 VÉRIFIER (3-6 mois, sans
  dépense) avant Étape 2 SÉCURISER, puis Étape 3 TU CHOISIS.
- Slide 11 : valeur révisée à ~320-700 k EUR (méthode coût de
  remplacement) + pont explicatif détaillant l'origine de la différence
  (raccordement 100-300k, autorisations 20-50k, amiante 25-55k, 3-4 ans
  gagnés). Chaque euro est désormais justifié par un coût évité.
- Slides 3 et 13 : ask ramené de 12-18 mois à 3-6 mois d'exclusivité de
  test ; jalons réordonnés (sonder le marché en premier).
- Ajout du script générateur du deck pour permettre les mises à jour.

Co-Authored-By: Claude Fable 5 <noreply@anthropic.com>
Claude-Session: https://claude.ai/code/session_0164UaLTCwXXHJS5FE273cpg
</commit_message>
<xml_diff>
--- a/deck/Deck-Foncier-Bel-Air.pptx
+++ b/deck/Deck-Foncier-Bel-Air.pptx
@@ -2956,12 +2956,12 @@
         </p:nvSpPr>
         <p:spPr>
           <a:xfrm>
-            <a:off x="640080" y="1965960"/>
-            <a:ext cx="5120640" cy="3703320"/>
+            <a:off x="640080" y="1874520"/>
+            <a:ext cx="5120640" cy="1783080"/>
           </a:xfrm>
           <a:prstGeom prst="roundRect">
             <a:avLst>
-              <a:gd name="adj" fmla="val 2469"/>
+              <a:gd name="adj" fmla="val 5128"/>
             </a:avLst>
           </a:prstGeom>
           <a:solidFill>
@@ -2983,7 +2983,7 @@
         </p:nvSpPr>
         <p:spPr>
           <a:xfrm>
-            <a:off x="914400" y="2194560"/>
+            <a:off x="914400" y="2029968"/>
             <a:ext cx="4572000" cy="365760"/>
           </a:xfrm>
           <a:prstGeom prst="rect">
@@ -3000,7 +3000,7 @@
               <a:buNone/>
             </a:pPr>
             <a:r>
-              <a:rPr lang="en-US" sz="1300" b="1" spc="100" kern="0" dirty="0">
+              <a:rPr lang="en-US" sz="1250" b="1" spc="100" kern="0" dirty="0">
                 <a:solidFill>
                   <a:srgbClr val="EC5F65"/>
                 </a:solidFill>
@@ -3010,7 +3010,7 @@
               </a:rPr>
               <a:t>VENTE BTP — MAINTENANT</a:t>
             </a:r>
-            <a:endParaRPr lang="en-US" sz="1300" dirty="0"/>
+            <a:endParaRPr lang="en-US" sz="1250" dirty="0"/>
           </a:p>
         </p:txBody>
       </p:sp>
@@ -3022,7 +3022,7 @@
         </p:nvSpPr>
         <p:spPr>
           <a:xfrm>
-            <a:off x="914400" y="2606040"/>
+            <a:off x="914400" y="2395728"/>
             <a:ext cx="4663440" cy="640080"/>
           </a:xfrm>
           <a:prstGeom prst="rect">
@@ -3039,7 +3039,7 @@
               <a:buNone/>
             </a:pPr>
             <a:r>
-              <a:rPr lang="en-US" sz="2700" b="1" dirty="0">
+              <a:rPr lang="en-US" sz="2600" b="1" dirty="0">
                 <a:solidFill>
                   <a:srgbClr val="1A2A31"/>
                 </a:solidFill>
@@ -3049,7 +3049,7 @@
               </a:rPr>
               <a:t>~164 000 – 340 000 €</a:t>
             </a:r>
-            <a:endParaRPr lang="en-US" sz="2700" dirty="0"/>
+            <a:endParaRPr lang="en-US" sz="2600" dirty="0"/>
           </a:p>
         </p:txBody>
       </p:sp>
@@ -3061,7 +3061,7 @@
         </p:nvSpPr>
         <p:spPr>
           <a:xfrm>
-            <a:off x="914400" y="3246120"/>
+            <a:off x="914400" y="3035808"/>
             <a:ext cx="4663440" cy="457200"/>
           </a:xfrm>
           <a:prstGeom prst="rect">
@@ -3086,7 +3086,7 @@
                 <a:ea typeface="Calibri" pitchFamily="34" charset="-122"/>
                 <a:cs typeface="Calibri" pitchFamily="34" charset="-120"/>
               </a:rPr>
-              <a:t>valeur foncière de marché (à confronter à l'offre reçue)</a:t>
+              <a:t>valeur de marché du terrain, passif amiante déduit</a:t>
             </a:r>
             <a:endParaRPr lang="en-US" sz="1250" dirty="0"/>
           </a:p>
@@ -3094,121 +3094,258 @@
       </p:sp>
       <p:sp>
         <p:nvSpPr>
-          <p:cNvPr id="8" name="Text 6"/>
-          <p:cNvSpPr/>
-          <p:nvPr/>
-        </p:nvSpPr>
-        <p:spPr>
-          <a:xfrm>
-            <a:off x="960120" y="3840480"/>
-            <a:ext cx="4572000" cy="1737360"/>
-          </a:xfrm>
-          <a:prstGeom prst="rect">
-            <a:avLst/>
-          </a:prstGeom>
-          <a:noFill/>
-          <a:ln/>
-        </p:spPr>
-        <p:txBody>
-          <a:bodyPr wrap="square" rtlCol="0" anchor="ctr"/>
-          <a:lstStyle/>
-          <a:p>
-            <a:pPr marL="342900" indent="-342900">
-              <a:spcAft>
-                <a:spcPts val="900"/>
-              </a:spcAft>
-              <a:buSzPct val="100000"/>
-              <a:buChar char="•"/>
-            </a:pPr>
-            <a:r>
-              <a:rPr lang="en-US" sz="1450" dirty="0">
-                <a:solidFill>
-                  <a:srgbClr val="1A2A31"/>
+          <p:cNvPr id="8" name="Shape 6"/>
+          <p:cNvSpPr/>
+          <p:nvPr/>
+        </p:nvSpPr>
+        <p:spPr>
+          <a:xfrm>
+            <a:off x="5989320" y="1874520"/>
+            <a:ext cx="5532120" cy="1783080"/>
+          </a:xfrm>
+          <a:prstGeom prst="roundRect">
+            <a:avLst>
+              <a:gd name="adj" fmla="val 5128"/>
+            </a:avLst>
+          </a:prstGeom>
+          <a:solidFill>
+            <a:srgbClr val="1B4355"/>
+          </a:solidFill>
+          <a:ln/>
+        </p:spPr>
+      </p:sp>
+      <p:sp>
+        <p:nvSpPr>
+          <p:cNvPr id="9" name="Text 7"/>
+          <p:cNvSpPr/>
+          <p:nvPr/>
+        </p:nvSpPr>
+        <p:spPr>
+          <a:xfrm>
+            <a:off x="6309360" y="2029968"/>
+            <a:ext cx="5029200" cy="365760"/>
+          </a:xfrm>
+          <a:prstGeom prst="rect">
+            <a:avLst/>
+          </a:prstGeom>
+          <a:noFill/>
+          <a:ln/>
+        </p:spPr>
+        <p:txBody>
+          <a:bodyPr wrap="square" rtlCol="0" anchor="ctr"/>
+          <a:lstStyle/>
+          <a:p>
+            <a:pPr indent="0" marL="0">
+              <a:buNone/>
+            </a:pPr>
+            <a:r>
+              <a:rPr lang="en-US" sz="1250" b="1" spc="100" kern="0" dirty="0">
+                <a:solidFill>
+                  <a:srgbClr val="00A19A"/>
                 </a:solidFill>
                 <a:latin typeface="Calibri" pitchFamily="34" charset="0"/>
                 <a:ea typeface="Calibri" pitchFamily="34" charset="-122"/>
                 <a:cs typeface="Calibri" pitchFamily="34" charset="-120"/>
               </a:rPr>
-              <a:t>Encaissement unique, définitif</a:t>
-            </a:r>
-            <a:endParaRPr lang="en-US" sz="1450" dirty="0"/>
-          </a:p>
-          <a:p>
-            <a:pPr marL="342900" indent="-342900">
-              <a:spcAft>
-                <a:spcPts val="900"/>
-              </a:spcAft>
-              <a:buSzPct val="100000"/>
-              <a:buChar char="•"/>
-            </a:pPr>
-            <a:r>
-              <a:rPr lang="en-US" sz="1450" dirty="0">
-                <a:solidFill>
-                  <a:srgbClr val="1A2A31"/>
+              <a:t>TERRAIN PRÊT À BÂTIR — APRÈS PRÉPARATION</a:t>
+            </a:r>
+            <a:endParaRPr lang="en-US" sz="1250" dirty="0"/>
+          </a:p>
+        </p:txBody>
+      </p:sp>
+      <p:sp>
+        <p:nvSpPr>
+          <p:cNvPr id="10" name="Text 8"/>
+          <p:cNvSpPr/>
+          <p:nvPr/>
+        </p:nvSpPr>
+        <p:spPr>
+          <a:xfrm>
+            <a:off x="6309360" y="2395728"/>
+            <a:ext cx="5029200" cy="640080"/>
+          </a:xfrm>
+          <a:prstGeom prst="rect">
+            <a:avLst/>
+          </a:prstGeom>
+          <a:noFill/>
+          <a:ln/>
+        </p:spPr>
+        <p:txBody>
+          <a:bodyPr wrap="square" rtlCol="0" anchor="ctr"/>
+          <a:lstStyle/>
+          <a:p>
+            <a:pPr indent="0" marL="0">
+              <a:buNone/>
+            </a:pPr>
+            <a:r>
+              <a:rPr lang="en-US" sz="2600" b="1" dirty="0">
+                <a:solidFill>
+                  <a:srgbClr val="FFDD00"/>
+                </a:solidFill>
+                <a:latin typeface="Cambria" pitchFamily="34" charset="0"/>
+                <a:ea typeface="Cambria" pitchFamily="34" charset="-122"/>
+                <a:cs typeface="Cambria" pitchFamily="34" charset="-120"/>
+              </a:rPr>
+              <a:t>~320 000 – 700 000 €</a:t>
+            </a:r>
+            <a:endParaRPr lang="en-US" sz="2600" dirty="0"/>
+          </a:p>
+        </p:txBody>
+      </p:sp>
+      <p:sp>
+        <p:nvSpPr>
+          <p:cNvPr id="11" name="Text 9"/>
+          <p:cNvSpPr/>
+          <p:nvPr/>
+        </p:nvSpPr>
+        <p:spPr>
+          <a:xfrm>
+            <a:off x="6309360" y="3035808"/>
+            <a:ext cx="5029200" cy="457200"/>
+          </a:xfrm>
+          <a:prstGeom prst="rect">
+            <a:avLst/>
+          </a:prstGeom>
+          <a:noFill/>
+          <a:ln/>
+        </p:spPr>
+        <p:txBody>
+          <a:bodyPr wrap="square" rtlCol="0" anchor="ctr"/>
+          <a:lstStyle/>
+          <a:p>
+            <a:pPr indent="0" marL="0">
+              <a:buNone/>
+            </a:pPr>
+            <a:r>
+              <a:rPr lang="en-US" sz="1250" i="1" dirty="0">
+                <a:solidFill>
+                  <a:srgbClr val="CFE0E3"/>
                 </a:solidFill>
                 <a:latin typeface="Calibri" pitchFamily="34" charset="0"/>
                 <a:ea typeface="Calibri" pitchFamily="34" charset="-122"/>
                 <a:cs typeface="Calibri" pitchFamily="34" charset="-120"/>
               </a:rPr>
-              <a:t>Passif amiante déduit</a:t>
-            </a:r>
-            <a:endParaRPr lang="en-US" sz="1450" dirty="0"/>
-          </a:p>
-          <a:p>
-            <a:pPr marL="342900" indent="-342900">
-              <a:spcAft>
-                <a:spcPts val="900"/>
-              </a:spcAft>
-              <a:buSzPct val="100000"/>
-              <a:buChar char="•"/>
-            </a:pPr>
-            <a:r>
-              <a:rPr lang="en-US" sz="1450" dirty="0">
+              <a:t>ou un loyer récurrent, si tu préfères garder le terrain</a:t>
+            </a:r>
+            <a:endParaRPr lang="en-US" sz="1250" dirty="0"/>
+          </a:p>
+        </p:txBody>
+      </p:sp>
+      <p:sp>
+        <p:nvSpPr>
+          <p:cNvPr id="12" name="Text 10"/>
+          <p:cNvSpPr/>
+          <p:nvPr/>
+        </p:nvSpPr>
+        <p:spPr>
+          <a:xfrm>
+            <a:off x="640080" y="3840480"/>
+            <a:ext cx="10881360" cy="411480"/>
+          </a:xfrm>
+          <a:prstGeom prst="rect">
+            <a:avLst/>
+          </a:prstGeom>
+          <a:noFill/>
+          <a:ln/>
+        </p:spPr>
+        <p:txBody>
+          <a:bodyPr wrap="square" rtlCol="0" anchor="ctr"/>
+          <a:lstStyle/>
+          <a:p>
+            <a:pPr indent="0" marL="0">
+              <a:buNone/>
+            </a:pPr>
+            <a:r>
+              <a:rPr lang="en-US" sz="1600" b="1" dirty="0">
                 <a:solidFill>
                   <a:srgbClr val="1A2A31"/>
+                </a:solidFill>
+                <a:latin typeface="Cambria" pitchFamily="34" charset="0"/>
+                <a:ea typeface="Cambria" pitchFamily="34" charset="-122"/>
+                <a:cs typeface="Cambria" pitchFamily="34" charset="-120"/>
+              </a:rPr>
+              <a:t>D'où vient la différence ? De ce que le terrain fait économiser à son acheteur.</a:t>
+            </a:r>
+            <a:endParaRPr lang="en-US" sz="1600" dirty="0"/>
+          </a:p>
+        </p:txBody>
+      </p:sp>
+      <p:sp>
+        <p:nvSpPr>
+          <p:cNvPr id="13" name="Shape 11"/>
+          <p:cNvSpPr/>
+          <p:nvPr/>
+        </p:nvSpPr>
+        <p:spPr>
+          <a:xfrm>
+            <a:off x="640080" y="4343400"/>
+            <a:ext cx="2578608" cy="1417320"/>
+          </a:xfrm>
+          <a:prstGeom prst="roundRect">
+            <a:avLst>
+              <a:gd name="adj" fmla="val 5161"/>
+            </a:avLst>
+          </a:prstGeom>
+          <a:solidFill>
+            <a:srgbClr val="F1F5F6"/>
+          </a:solidFill>
+          <a:ln w="12700">
+            <a:solidFill>
+              <a:srgbClr val="D8E2E4"/>
+            </a:solidFill>
+            <a:prstDash val="solid"/>
+          </a:ln>
+        </p:spPr>
+      </p:sp>
+      <p:sp>
+        <p:nvSpPr>
+          <p:cNvPr id="14" name="Text 12"/>
+          <p:cNvSpPr/>
+          <p:nvPr/>
+        </p:nvSpPr>
+        <p:spPr>
+          <a:xfrm>
+            <a:off x="822960" y="4480560"/>
+            <a:ext cx="2240280" cy="320040"/>
+          </a:xfrm>
+          <a:prstGeom prst="rect">
+            <a:avLst/>
+          </a:prstGeom>
+          <a:noFill/>
+          <a:ln/>
+        </p:spPr>
+        <p:txBody>
+          <a:bodyPr wrap="square" rtlCol="0" anchor="ctr"/>
+          <a:lstStyle/>
+          <a:p>
+            <a:pPr indent="0" marL="0">
+              <a:buNone/>
+            </a:pPr>
+            <a:r>
+              <a:rPr lang="en-US" sz="1200" b="1" dirty="0">
+                <a:solidFill>
+                  <a:srgbClr val="5E7076"/>
                 </a:solidFill>
                 <a:latin typeface="Calibri" pitchFamily="34" charset="0"/>
                 <a:ea typeface="Calibri" pitchFamily="34" charset="-122"/>
                 <a:cs typeface="Calibri" pitchFamily="34" charset="-120"/>
               </a:rPr>
-              <a:t>Tu sors de l'actif</a:t>
-            </a:r>
-            <a:endParaRPr lang="en-US" sz="1450" dirty="0"/>
-          </a:p>
-        </p:txBody>
-      </p:sp>
-      <p:sp>
-        <p:nvSpPr>
-          <p:cNvPr id="9" name="Shape 7"/>
-          <p:cNvSpPr/>
-          <p:nvPr/>
-        </p:nvSpPr>
-        <p:spPr>
-          <a:xfrm>
-            <a:off x="5989320" y="1965960"/>
-            <a:ext cx="5532120" cy="3703320"/>
-          </a:xfrm>
-          <a:prstGeom prst="roundRect">
-            <a:avLst>
-              <a:gd name="adj" fmla="val 2469"/>
-            </a:avLst>
-          </a:prstGeom>
-          <a:solidFill>
-            <a:srgbClr val="1B4355"/>
-          </a:solidFill>
-          <a:ln/>
-        </p:spPr>
-      </p:sp>
-      <p:sp>
-        <p:nvSpPr>
-          <p:cNvPr id="10" name="Text 8"/>
-          <p:cNvSpPr/>
-          <p:nvPr/>
-        </p:nvSpPr>
-        <p:spPr>
-          <a:xfrm>
-            <a:off x="6309360" y="2194560"/>
-            <a:ext cx="5029200" cy="365760"/>
+              <a:t>Raccordement</a:t>
+            </a:r>
+            <a:endParaRPr lang="en-US" sz="1200" dirty="0"/>
+          </a:p>
+        </p:txBody>
+      </p:sp>
+      <p:sp>
+        <p:nvSpPr>
+          <p:cNvPr id="15" name="Text 13"/>
+          <p:cNvSpPr/>
+          <p:nvPr/>
+        </p:nvSpPr>
+        <p:spPr>
+          <a:xfrm>
+            <a:off x="822960" y="4791456"/>
+            <a:ext cx="2240280" cy="411480"/>
           </a:xfrm>
           <a:prstGeom prst="rect">
             <a:avLst/>
@@ -3224,30 +3361,96 @@
               <a:buNone/>
             </a:pPr>
             <a:r>
-              <a:rPr lang="en-US" sz="1300" b="1" spc="100" kern="0" dirty="0">
+              <a:rPr lang="en-US" sz="1700" b="1" dirty="0">
                 <a:solidFill>
                   <a:srgbClr val="00A19A"/>
+                </a:solidFill>
+                <a:latin typeface="Cambria" pitchFamily="34" charset="0"/>
+                <a:ea typeface="Cambria" pitchFamily="34" charset="-122"/>
+                <a:cs typeface="Cambria" pitchFamily="34" charset="-120"/>
+              </a:rPr>
+              <a:t>100 – 300 k€</a:t>
+            </a:r>
+            <a:endParaRPr lang="en-US" sz="1700" dirty="0"/>
+          </a:p>
+        </p:txBody>
+      </p:sp>
+      <p:sp>
+        <p:nvSpPr>
+          <p:cNvPr id="16" name="Text 14"/>
+          <p:cNvSpPr/>
+          <p:nvPr/>
+        </p:nvSpPr>
+        <p:spPr>
+          <a:xfrm>
+            <a:off x="822960" y="5230368"/>
+            <a:ext cx="2240280" cy="457200"/>
+          </a:xfrm>
+          <a:prstGeom prst="rect">
+            <a:avLst/>
+          </a:prstGeom>
+          <a:noFill/>
+          <a:ln/>
+        </p:spPr>
+        <p:txBody>
+          <a:bodyPr wrap="square" rtlCol="0" anchor="ctr"/>
+          <a:lstStyle/>
+          <a:p>
+            <a:pPr indent="0" marL="0">
+              <a:buNone/>
+            </a:pPr>
+            <a:r>
+              <a:rPr lang="en-US" sz="1150" dirty="0">
+                <a:solidFill>
+                  <a:srgbClr val="5E7076"/>
                 </a:solidFill>
                 <a:latin typeface="Calibri" pitchFamily="34" charset="0"/>
                 <a:ea typeface="Calibri" pitchFamily="34" charset="-122"/>
                 <a:cs typeface="Calibri" pitchFamily="34" charset="-120"/>
               </a:rPr>
-              <a:t>VOIE DATA CENTER — APRÈS DÉ-RISQUAGE</a:t>
-            </a:r>
-            <a:endParaRPr lang="en-US" sz="1300" dirty="0"/>
-          </a:p>
-        </p:txBody>
-      </p:sp>
-      <p:sp>
-        <p:nvSpPr>
-          <p:cNvPr id="11" name="Text 9"/>
-          <p:cNvSpPr/>
-          <p:nvPr/>
-        </p:nvSpPr>
-        <p:spPr>
-          <a:xfrm>
-            <a:off x="6309360" y="2606040"/>
-            <a:ext cx="5029200" cy="640080"/>
+              <a:t>le branchement électrique est déjà réglé</a:t>
+            </a:r>
+            <a:endParaRPr lang="en-US" sz="1150" dirty="0"/>
+          </a:p>
+        </p:txBody>
+      </p:sp>
+      <p:sp>
+        <p:nvSpPr>
+          <p:cNvPr id="17" name="Shape 15"/>
+          <p:cNvSpPr/>
+          <p:nvPr/>
+        </p:nvSpPr>
+        <p:spPr>
+          <a:xfrm>
+            <a:off x="3401568" y="4343400"/>
+            <a:ext cx="2578608" cy="1417320"/>
+          </a:xfrm>
+          <a:prstGeom prst="roundRect">
+            <a:avLst>
+              <a:gd name="adj" fmla="val 5161"/>
+            </a:avLst>
+          </a:prstGeom>
+          <a:solidFill>
+            <a:srgbClr val="F1F5F6"/>
+          </a:solidFill>
+          <a:ln w="12700">
+            <a:solidFill>
+              <a:srgbClr val="D8E2E4"/>
+            </a:solidFill>
+            <a:prstDash val="solid"/>
+          </a:ln>
+        </p:spPr>
+      </p:sp>
+      <p:sp>
+        <p:nvSpPr>
+          <p:cNvPr id="18" name="Text 16"/>
+          <p:cNvSpPr/>
+          <p:nvPr/>
+        </p:nvSpPr>
+        <p:spPr>
+          <a:xfrm>
+            <a:off x="3584448" y="4480560"/>
+            <a:ext cx="2240280" cy="320040"/>
           </a:xfrm>
           <a:prstGeom prst="rect">
             <a:avLst/>
@@ -3263,30 +3466,69 @@
               <a:buNone/>
             </a:pPr>
             <a:r>
-              <a:rPr lang="en-US" sz="2700" b="1" dirty="0">
-                <a:solidFill>
-                  <a:srgbClr val="FFDD00"/>
+              <a:rPr lang="en-US" sz="1200" b="1" dirty="0">
+                <a:solidFill>
+                  <a:srgbClr val="5E7076"/>
+                </a:solidFill>
+                <a:latin typeface="Calibri" pitchFamily="34" charset="0"/>
+                <a:ea typeface="Calibri" pitchFamily="34" charset="-122"/>
+                <a:cs typeface="Calibri" pitchFamily="34" charset="-120"/>
+              </a:rPr>
+              <a:t>Autorisations</a:t>
+            </a:r>
+            <a:endParaRPr lang="en-US" sz="1200" dirty="0"/>
+          </a:p>
+        </p:txBody>
+      </p:sp>
+      <p:sp>
+        <p:nvSpPr>
+          <p:cNvPr id="19" name="Text 17"/>
+          <p:cNvSpPr/>
+          <p:nvPr/>
+        </p:nvSpPr>
+        <p:spPr>
+          <a:xfrm>
+            <a:off x="3584448" y="4791456"/>
+            <a:ext cx="2240280" cy="411480"/>
+          </a:xfrm>
+          <a:prstGeom prst="rect">
+            <a:avLst/>
+          </a:prstGeom>
+          <a:noFill/>
+          <a:ln/>
+        </p:spPr>
+        <p:txBody>
+          <a:bodyPr wrap="square" rtlCol="0" anchor="ctr"/>
+          <a:lstStyle/>
+          <a:p>
+            <a:pPr indent="0" marL="0">
+              <a:buNone/>
+            </a:pPr>
+            <a:r>
+              <a:rPr lang="en-US" sz="1700" b="1" dirty="0">
+                <a:solidFill>
+                  <a:srgbClr val="00A19A"/>
                 </a:solidFill>
                 <a:latin typeface="Cambria" pitchFamily="34" charset="0"/>
                 <a:ea typeface="Cambria" pitchFamily="34" charset="-122"/>
                 <a:cs typeface="Cambria" pitchFamily="34" charset="-120"/>
               </a:rPr>
-              <a:t>~250 000 – 1 000 000 €</a:t>
-            </a:r>
-            <a:endParaRPr lang="en-US" sz="2700" dirty="0"/>
-          </a:p>
-        </p:txBody>
-      </p:sp>
-      <p:sp>
-        <p:nvSpPr>
-          <p:cNvPr id="12" name="Text 10"/>
-          <p:cNvSpPr/>
-          <p:nvPr/>
-        </p:nvSpPr>
-        <p:spPr>
-          <a:xfrm>
-            <a:off x="6309360" y="3246120"/>
-            <a:ext cx="5029200" cy="457200"/>
+              <a:t>20 – 50 k€</a:t>
+            </a:r>
+            <a:endParaRPr lang="en-US" sz="1700" dirty="0"/>
+          </a:p>
+        </p:txBody>
+      </p:sp>
+      <p:sp>
+        <p:nvSpPr>
+          <p:cNvPr id="20" name="Text 18"/>
+          <p:cNvSpPr/>
+          <p:nvPr/>
+        </p:nvSpPr>
+        <p:spPr>
+          <a:xfrm>
+            <a:off x="3584448" y="5230368"/>
+            <a:ext cx="2240280" cy="457200"/>
           </a:xfrm>
           <a:prstGeom prst="rect">
             <a:avLst/>
@@ -3302,131 +3544,295 @@
               <a:buNone/>
             </a:pPr>
             <a:r>
-              <a:rPr lang="en-US" sz="1250" i="1" dirty="0">
-                <a:solidFill>
-                  <a:srgbClr val="CFE0E3"/>
+              <a:rPr lang="en-US" sz="1150" dirty="0">
+                <a:solidFill>
+                  <a:srgbClr val="5E7076"/>
                 </a:solidFill>
                 <a:latin typeface="Calibri" pitchFamily="34" charset="0"/>
                 <a:ea typeface="Calibri" pitchFamily="34" charset="-122"/>
                 <a:cs typeface="Calibri" pitchFamily="34" charset="-120"/>
               </a:rPr>
-              <a:t>survaleur × 1,5 à 3 en vente  —  ou un loyer récurrent</a:t>
-            </a:r>
-            <a:endParaRPr lang="en-US" sz="1250" dirty="0"/>
-          </a:p>
-        </p:txBody>
-      </p:sp>
-      <p:sp>
-        <p:nvSpPr>
-          <p:cNvPr id="13" name="Text 11"/>
-          <p:cNvSpPr/>
-          <p:nvPr/>
-        </p:nvSpPr>
-        <p:spPr>
-          <a:xfrm>
-            <a:off x="6355080" y="3840480"/>
-            <a:ext cx="4937760" cy="1737360"/>
-          </a:xfrm>
-          <a:prstGeom prst="rect">
-            <a:avLst/>
-          </a:prstGeom>
-          <a:noFill/>
-          <a:ln/>
-        </p:spPr>
-        <p:txBody>
-          <a:bodyPr wrap="square" rtlCol="0" anchor="ctr"/>
-          <a:lstStyle/>
-          <a:p>
-            <a:pPr marL="342900" indent="-342900">
-              <a:spcAft>
-                <a:spcPts val="900"/>
-              </a:spcAft>
-              <a:buSzPct val="100000"/>
-              <a:buChar char="•"/>
-            </a:pPr>
-            <a:r>
-              <a:rPr lang="en-US" sz="1450" dirty="0">
-                <a:solidFill>
-                  <a:srgbClr val="E6EFF0"/>
+              <a:t>permis obtenu, plus aucun aléa</a:t>
+            </a:r>
+            <a:endParaRPr lang="en-US" sz="1150" dirty="0"/>
+          </a:p>
+        </p:txBody>
+      </p:sp>
+      <p:sp>
+        <p:nvSpPr>
+          <p:cNvPr id="21" name="Shape 19"/>
+          <p:cNvSpPr/>
+          <p:nvPr/>
+        </p:nvSpPr>
+        <p:spPr>
+          <a:xfrm>
+            <a:off x="6163056" y="4343400"/>
+            <a:ext cx="2578608" cy="1417320"/>
+          </a:xfrm>
+          <a:prstGeom prst="roundRect">
+            <a:avLst>
+              <a:gd name="adj" fmla="val 5161"/>
+            </a:avLst>
+          </a:prstGeom>
+          <a:solidFill>
+            <a:srgbClr val="F1F5F6"/>
+          </a:solidFill>
+          <a:ln w="12700">
+            <a:solidFill>
+              <a:srgbClr val="D8E2E4"/>
+            </a:solidFill>
+            <a:prstDash val="solid"/>
+          </a:ln>
+        </p:spPr>
+      </p:sp>
+      <p:sp>
+        <p:nvSpPr>
+          <p:cNvPr id="22" name="Text 20"/>
+          <p:cNvSpPr/>
+          <p:nvPr/>
+        </p:nvSpPr>
+        <p:spPr>
+          <a:xfrm>
+            <a:off x="6345936" y="4480560"/>
+            <a:ext cx="2240280" cy="320040"/>
+          </a:xfrm>
+          <a:prstGeom prst="rect">
+            <a:avLst/>
+          </a:prstGeom>
+          <a:noFill/>
+          <a:ln/>
+        </p:spPr>
+        <p:txBody>
+          <a:bodyPr wrap="square" rtlCol="0" anchor="ctr"/>
+          <a:lstStyle/>
+          <a:p>
+            <a:pPr indent="0" marL="0">
+              <a:buNone/>
+            </a:pPr>
+            <a:r>
+              <a:rPr lang="en-US" sz="1200" b="1" dirty="0">
+                <a:solidFill>
+                  <a:srgbClr val="5E7076"/>
                 </a:solidFill>
                 <a:latin typeface="Calibri" pitchFamily="34" charset="0"/>
                 <a:ea typeface="Calibri" pitchFamily="34" charset="-122"/>
                 <a:cs typeface="Calibri" pitchFamily="34" charset="-120"/>
               </a:rPr>
-              <a:t>Vente premium OU loyer sur 20-40 ans</a:t>
-            </a:r>
-            <a:endParaRPr lang="en-US" sz="1450" dirty="0"/>
-          </a:p>
-          <a:p>
-            <a:pPr marL="342900" indent="-342900">
-              <a:spcAft>
-                <a:spcPts val="900"/>
-              </a:spcAft>
-              <a:buSzPct val="100000"/>
-              <a:buChar char="•"/>
-            </a:pPr>
-            <a:r>
-              <a:rPr lang="en-US" sz="1450" dirty="0">
-                <a:solidFill>
-                  <a:srgbClr val="E6EFF0"/>
+              <a:t>Amiante traité</a:t>
+            </a:r>
+            <a:endParaRPr lang="en-US" sz="1200" dirty="0"/>
+          </a:p>
+        </p:txBody>
+      </p:sp>
+      <p:sp>
+        <p:nvSpPr>
+          <p:cNvPr id="23" name="Text 21"/>
+          <p:cNvSpPr/>
+          <p:nvPr/>
+        </p:nvSpPr>
+        <p:spPr>
+          <a:xfrm>
+            <a:off x="6345936" y="4791456"/>
+            <a:ext cx="2240280" cy="411480"/>
+          </a:xfrm>
+          <a:prstGeom prst="rect">
+            <a:avLst/>
+          </a:prstGeom>
+          <a:noFill/>
+          <a:ln/>
+        </p:spPr>
+        <p:txBody>
+          <a:bodyPr wrap="square" rtlCol="0" anchor="ctr"/>
+          <a:lstStyle/>
+          <a:p>
+            <a:pPr indent="0" marL="0">
+              <a:buNone/>
+            </a:pPr>
+            <a:r>
+              <a:rPr lang="en-US" sz="1700" b="1" dirty="0">
+                <a:solidFill>
+                  <a:srgbClr val="00A19A"/>
+                </a:solidFill>
+                <a:latin typeface="Cambria" pitchFamily="34" charset="0"/>
+                <a:ea typeface="Cambria" pitchFamily="34" charset="-122"/>
+                <a:cs typeface="Cambria" pitchFamily="34" charset="-120"/>
+              </a:rPr>
+              <a:t>25 – 55 k€</a:t>
+            </a:r>
+            <a:endParaRPr lang="en-US" sz="1700" dirty="0"/>
+          </a:p>
+        </p:txBody>
+      </p:sp>
+      <p:sp>
+        <p:nvSpPr>
+          <p:cNvPr id="24" name="Text 22"/>
+          <p:cNvSpPr/>
+          <p:nvPr/>
+        </p:nvSpPr>
+        <p:spPr>
+          <a:xfrm>
+            <a:off x="6345936" y="5230368"/>
+            <a:ext cx="2240280" cy="457200"/>
+          </a:xfrm>
+          <a:prstGeom prst="rect">
+            <a:avLst/>
+          </a:prstGeom>
+          <a:noFill/>
+          <a:ln/>
+        </p:spPr>
+        <p:txBody>
+          <a:bodyPr wrap="square" rtlCol="0" anchor="ctr"/>
+          <a:lstStyle/>
+          <a:p>
+            <a:pPr indent="0" marL="0">
+              <a:buNone/>
+            </a:pPr>
+            <a:r>
+              <a:rPr lang="en-US" sz="1150" dirty="0">
+                <a:solidFill>
+                  <a:srgbClr val="5E7076"/>
                 </a:solidFill>
                 <a:latin typeface="Calibri" pitchFamily="34" charset="0"/>
                 <a:ea typeface="Calibri" pitchFamily="34" charset="-122"/>
                 <a:cs typeface="Calibri" pitchFamily="34" charset="-120"/>
               </a:rPr>
-              <a:t>Amiante pris en charge par le projet</a:t>
-            </a:r>
-            <a:endParaRPr lang="en-US" sz="1450" dirty="0"/>
-          </a:p>
-          <a:p>
-            <a:pPr marL="342900" indent="-342900">
-              <a:spcAft>
-                <a:spcPts val="900"/>
-              </a:spcAft>
-              <a:buSzPct val="100000"/>
-              <a:buChar char="•"/>
-            </a:pPr>
-            <a:r>
-              <a:rPr lang="en-US" sz="1450" dirty="0">
-                <a:solidFill>
-                  <a:srgbClr val="E6EFF0"/>
+              <a:t>terrain propre, prêt à construire</a:t>
+            </a:r>
+            <a:endParaRPr lang="en-US" sz="1150" dirty="0"/>
+          </a:p>
+        </p:txBody>
+      </p:sp>
+      <p:sp>
+        <p:nvSpPr>
+          <p:cNvPr id="25" name="Shape 23"/>
+          <p:cNvSpPr/>
+          <p:nvPr/>
+        </p:nvSpPr>
+        <p:spPr>
+          <a:xfrm>
+            <a:off x="8924544" y="4343400"/>
+            <a:ext cx="2578608" cy="1417320"/>
+          </a:xfrm>
+          <a:prstGeom prst="roundRect">
+            <a:avLst>
+              <a:gd name="adj" fmla="val 5161"/>
+            </a:avLst>
+          </a:prstGeom>
+          <a:solidFill>
+            <a:srgbClr val="F1F5F6"/>
+          </a:solidFill>
+          <a:ln w="12700">
+            <a:solidFill>
+              <a:srgbClr val="D8E2E4"/>
+            </a:solidFill>
+            <a:prstDash val="solid"/>
+          </a:ln>
+        </p:spPr>
+      </p:sp>
+      <p:sp>
+        <p:nvSpPr>
+          <p:cNvPr id="26" name="Text 24"/>
+          <p:cNvSpPr/>
+          <p:nvPr/>
+        </p:nvSpPr>
+        <p:spPr>
+          <a:xfrm>
+            <a:off x="9107424" y="4480560"/>
+            <a:ext cx="2240280" cy="320040"/>
+          </a:xfrm>
+          <a:prstGeom prst="rect">
+            <a:avLst/>
+          </a:prstGeom>
+          <a:noFill/>
+          <a:ln/>
+        </p:spPr>
+        <p:txBody>
+          <a:bodyPr wrap="square" rtlCol="0" anchor="ctr"/>
+          <a:lstStyle/>
+          <a:p>
+            <a:pPr indent="0" marL="0">
+              <a:buNone/>
+            </a:pPr>
+            <a:r>
+              <a:rPr lang="en-US" sz="1200" b="1" dirty="0">
+                <a:solidFill>
+                  <a:srgbClr val="5E7076"/>
                 </a:solidFill>
                 <a:latin typeface="Calibri" pitchFamily="34" charset="0"/>
                 <a:ea typeface="Calibri" pitchFamily="34" charset="-122"/>
                 <a:cs typeface="Calibri" pitchFamily="34" charset="-120"/>
               </a:rPr>
-              <a:t>Tu peux garder le foncier (patrimoine)</a:t>
-            </a:r>
-            <a:endParaRPr lang="en-US" sz="1450" dirty="0"/>
-          </a:p>
-        </p:txBody>
-      </p:sp>
-      <p:sp>
-        <p:nvSpPr>
-          <p:cNvPr id="14" name="Text 12"/>
-          <p:cNvSpPr/>
-          <p:nvPr/>
-        </p:nvSpPr>
-        <p:spPr>
-          <a:xfrm>
-            <a:off x="640080" y="5897880"/>
-            <a:ext cx="10972800" cy="457200"/>
-          </a:xfrm>
-          <a:prstGeom prst="rect">
-            <a:avLst/>
-          </a:prstGeom>
-          <a:noFill/>
-          <a:ln/>
-        </p:spPr>
-        <p:txBody>
-          <a:bodyPr wrap="square" rtlCol="0" anchor="ctr"/>
-          <a:lstStyle/>
-          <a:p>
-            <a:pPr algn="ctr" indent="0" marL="0">
-              <a:buNone/>
-            </a:pPr>
-            <a:r>
-              <a:rPr lang="en-US" sz="1350" i="1" dirty="0">
+              <a:t>Temps gagné</a:t>
+            </a:r>
+            <a:endParaRPr lang="en-US" sz="1200" dirty="0"/>
+          </a:p>
+        </p:txBody>
+      </p:sp>
+      <p:sp>
+        <p:nvSpPr>
+          <p:cNvPr id="27" name="Text 25"/>
+          <p:cNvSpPr/>
+          <p:nvPr/>
+        </p:nvSpPr>
+        <p:spPr>
+          <a:xfrm>
+            <a:off x="9107424" y="4791456"/>
+            <a:ext cx="2240280" cy="411480"/>
+          </a:xfrm>
+          <a:prstGeom prst="rect">
+            <a:avLst/>
+          </a:prstGeom>
+          <a:noFill/>
+          <a:ln/>
+        </p:spPr>
+        <p:txBody>
+          <a:bodyPr wrap="square" rtlCol="0" anchor="ctr"/>
+          <a:lstStyle/>
+          <a:p>
+            <a:pPr indent="0" marL="0">
+              <a:buNone/>
+            </a:pPr>
+            <a:r>
+              <a:rPr lang="en-US" sz="1700" b="1" dirty="0">
+                <a:solidFill>
+                  <a:srgbClr val="00A19A"/>
+                </a:solidFill>
+                <a:latin typeface="Cambria" pitchFamily="34" charset="0"/>
+                <a:ea typeface="Cambria" pitchFamily="34" charset="-122"/>
+                <a:cs typeface="Cambria" pitchFamily="34" charset="-120"/>
+              </a:rPr>
+              <a:t>3 à 4 ans</a:t>
+            </a:r>
+            <a:endParaRPr lang="en-US" sz="1700" dirty="0"/>
+          </a:p>
+        </p:txBody>
+      </p:sp>
+      <p:sp>
+        <p:nvSpPr>
+          <p:cNvPr id="28" name="Text 26"/>
+          <p:cNvSpPr/>
+          <p:nvPr/>
+        </p:nvSpPr>
+        <p:spPr>
+          <a:xfrm>
+            <a:off x="9107424" y="5230368"/>
+            <a:ext cx="2240280" cy="457200"/>
+          </a:xfrm>
+          <a:prstGeom prst="rect">
+            <a:avLst/>
+          </a:prstGeom>
+          <a:noFill/>
+          <a:ln/>
+        </p:spPr>
+        <p:txBody>
+          <a:bodyPr wrap="square" rtlCol="0" anchor="ctr"/>
+          <a:lstStyle/>
+          <a:p>
+            <a:pPr indent="0" marL="0">
+              <a:buNone/>
+            </a:pPr>
+            <a:r>
+              <a:rPr lang="en-US" sz="1150" dirty="0">
                 <a:solidFill>
                   <a:srgbClr val="5E7076"/>
                 </a:solidFill>
@@ -3434,15 +3840,54 @@
                 <a:ea typeface="Calibri" pitchFamily="34" charset="-122"/>
                 <a:cs typeface="Calibri" pitchFamily="34" charset="-120"/>
               </a:rPr>
-              <a:t>Condition : trouver l'acheteur ou l'exploitant — c'est justement ce que je vais dé-risquer.</a:t>
-            </a:r>
-            <a:endParaRPr lang="en-US" sz="1350" dirty="0"/>
-          </a:p>
-        </p:txBody>
-      </p:sp>
-      <p:sp>
-        <p:nvSpPr>
-          <p:cNvPr id="15" name="Text 13"/>
+              <a:t>le vrai moteur de la valeur</a:t>
+            </a:r>
+            <a:endParaRPr lang="en-US" sz="1150" dirty="0"/>
+          </a:p>
+        </p:txBody>
+      </p:sp>
+      <p:sp>
+        <p:nvSpPr>
+          <p:cNvPr id="29" name="Text 27"/>
+          <p:cNvSpPr/>
+          <p:nvPr/>
+        </p:nvSpPr>
+        <p:spPr>
+          <a:xfrm>
+            <a:off x="640080" y="5897880"/>
+            <a:ext cx="10881360" cy="411480"/>
+          </a:xfrm>
+          <a:prstGeom prst="rect">
+            <a:avLst/>
+          </a:prstGeom>
+          <a:noFill/>
+          <a:ln/>
+        </p:spPr>
+        <p:txBody>
+          <a:bodyPr wrap="square" rtlCol="0" anchor="ctr"/>
+          <a:lstStyle/>
+          <a:p>
+            <a:pPr algn="ctr" indent="0" marL="0">
+              <a:buNone/>
+            </a:pPr>
+            <a:r>
+              <a:rPr lang="en-US" sz="1300" i="1" dirty="0">
+                <a:solidFill>
+                  <a:srgbClr val="5E7076"/>
+                </a:solidFill>
+                <a:latin typeface="Calibri" pitchFamily="34" charset="0"/>
+                <a:ea typeface="Calibri" pitchFamily="34" charset="-122"/>
+                <a:cs typeface="Calibri" pitchFamily="34" charset="-120"/>
+              </a:rPr>
+              <a:t>Chaque euro de cette différence correspond à un coût réel que l'acheteur n'aura pas à payer.</a:t>
+            </a:r>
+            <a:endParaRPr lang="en-US" sz="1300" dirty="0"/>
+          </a:p>
+        </p:txBody>
+      </p:sp>
+      <p:sp>
+        <p:nvSpPr>
+          <p:cNvPr id="30" name="Text 28"/>
           <p:cNvSpPr/>
           <p:nvPr/>
         </p:nvSpPr>
@@ -4548,7 +4993,7 @@
                 <a:ea typeface="Cambria" pitchFamily="34" charset="-122"/>
                 <a:cs typeface="Cambria" pitchFamily="34" charset="-120"/>
               </a:rPr>
-              <a:t>Mois 1-3</a:t>
+              <a:t>Mois 1-2</a:t>
             </a:r>
             <a:endParaRPr lang="en-US" sz="1450" dirty="0"/>
           </a:p>
@@ -4587,7 +5032,7 @@
                 <a:ea typeface="Calibri" pitchFamily="34" charset="-122"/>
                 <a:cs typeface="Calibri" pitchFamily="34" charset="-120"/>
               </a:rPr>
-              <a:t>Pré-étude Enedis + rendez-vous à la mairie de Rodez</a:t>
+              <a:t>Contacter les spécialistes du foncier data center et les opérateurs</a:t>
             </a:r>
             <a:endParaRPr lang="en-US" sz="1300" dirty="0"/>
           </a:p>
@@ -4708,7 +5153,7 @@
                 <a:ea typeface="Cambria" pitchFamily="34" charset="-122"/>
                 <a:cs typeface="Cambria" pitchFamily="34" charset="-120"/>
               </a:rPr>
-              <a:t>Mois 3-9</a:t>
+              <a:t>Mois 2-4</a:t>
             </a:r>
             <a:endParaRPr lang="en-US" sz="1450" dirty="0"/>
           </a:p>
@@ -4747,7 +5192,7 @@
                 <a:ea typeface="Calibri" pitchFamily="34" charset="-122"/>
                 <a:cs typeface="Calibri" pitchFamily="34" charset="-120"/>
               </a:rPr>
-              <a:t>Réserver la puissance + certificat d'urbanisme</a:t>
+              <a:t>Premier rendez-vous à la mairie + pré-étude Enedis (gratuite)</a:t>
             </a:r>
             <a:endParaRPr lang="en-US" sz="1300" dirty="0"/>
           </a:p>
@@ -4868,7 +5313,7 @@
                 <a:ea typeface="Cambria" pitchFamily="34" charset="-122"/>
                 <a:cs typeface="Cambria" pitchFamily="34" charset="-120"/>
               </a:rPr>
-              <a:t>Mois 6-12</a:t>
+              <a:t>Mois 4-6</a:t>
             </a:r>
             <a:endParaRPr lang="en-US" sz="1450" dirty="0"/>
           </a:p>
@@ -4907,7 +5352,7 @@
                 <a:ea typeface="Calibri" pitchFamily="34" charset="-122"/>
                 <a:cs typeface="Calibri" pitchFamily="34" charset="-120"/>
               </a:rPr>
-              <a:t>Sonder acheteurs / exploitants (edge, colocation régionale)</a:t>
+              <a:t>Je te rapporte les réponses : y a-t-il un acheteur, à quel prix ?</a:t>
             </a:r>
             <a:endParaRPr lang="en-US" sz="1300" dirty="0"/>
           </a:p>
@@ -5044,7 +5489,7 @@
                 <a:ea typeface="Calibri" pitchFamily="34" charset="-122"/>
                 <a:cs typeface="Calibri" pitchFamily="34" charset="-120"/>
               </a:rPr>
-              <a:t>On décide ensemble, en fonction des résultats</a:t>
+              <a:t>On décide ensemble — continuer, ou vendre au BTP</a:t>
             </a:r>
             <a:endParaRPr lang="en-US" sz="1300" dirty="0"/>
           </a:p>
@@ -5148,7 +5593,7 @@
                 <a:ea typeface="Calibri" pitchFamily="34" charset="-122"/>
                 <a:cs typeface="Calibri" pitchFamily="34" charset="-120"/>
               </a:rPr>
-              <a:t>Ne pas signer la vente BTP maintenant</a:t>
+              <a:t>Ne pas signer la vente BTP tout de suite</a:t>
             </a:r>
             <a:endParaRPr lang="en-US" sz="1550" dirty="0"/>
           </a:p>
@@ -5169,7 +5614,7 @@
                 <a:ea typeface="Calibri" pitchFamily="34" charset="-122"/>
                 <a:cs typeface="Calibri" pitchFamily="34" charset="-120"/>
               </a:rPr>
-              <a:t>M'accorder 12-18 mois d'exclusivité (promesse sous conditions, ou option)</a:t>
+              <a:t>M'accorder 3 à 6 mois d'exclusivité, le temps de vérifier</a:t>
             </a:r>
             <a:endParaRPr lang="en-US" sz="1550" dirty="0"/>
           </a:p>
@@ -5190,7 +5635,7 @@
                 <a:ea typeface="Calibri" pitchFamily="34" charset="-122"/>
                 <a:cs typeface="Calibri" pitchFamily="34" charset="-120"/>
               </a:rPr>
-              <a:t>Étudier le projet ensemble, en transparence</a:t>
+              <a:t>Refaire le point ensemble avec les réponses en main</a:t>
             </a:r>
             <a:endParaRPr lang="en-US" sz="1550" dirty="0"/>
           </a:p>
@@ -5204,7 +5649,7 @@
         </p:nvSpPr>
         <p:spPr>
           <a:xfrm>
-            <a:off x="6492240" y="5074920"/>
+            <a:off x="6492240" y="5029200"/>
             <a:ext cx="4709160" cy="0"/>
           </a:xfrm>
           <a:prstGeom prst="line">
@@ -5227,8 +5672,8 @@
         </p:nvSpPr>
         <p:spPr>
           <a:xfrm>
-            <a:off x="6492240" y="5212080"/>
-            <a:ext cx="4754880" cy="777240"/>
+            <a:off x="6492240" y="5166360"/>
+            <a:ext cx="4754880" cy="822960"/>
           </a:xfrm>
           <a:prstGeom prst="rect">
             <a:avLst/>
@@ -5252,7 +5697,24 @@
                 <a:ea typeface="Calibri" pitchFamily="34" charset="-122"/>
                 <a:cs typeface="Calibri" pitchFamily="34" charset="-120"/>
               </a:rPr>
-              <a:t>Tu ne t'engages sur rien de définitif — tu te donnes une chance de valoir plus.</a:t>
+              <a:t>Je ne te demande pas de parier sur ce projet.</a:t>
+            </a:r>
+            <a:endParaRPr lang="en-US" sz="1400" dirty="0"/>
+          </a:p>
+          <a:p>
+            <a:pPr indent="0" marL="0">
+              <a:buNone/>
+            </a:pPr>
+            <a:r>
+              <a:rPr lang="en-US" sz="1400" i="1" dirty="0">
+                <a:solidFill>
+                  <a:srgbClr val="00A19A"/>
+                </a:solidFill>
+                <a:latin typeface="Calibri" pitchFamily="34" charset="0"/>
+                <a:ea typeface="Calibri" pitchFamily="34" charset="-122"/>
+                <a:cs typeface="Calibri" pitchFamily="34" charset="-120"/>
+              </a:rPr>
+              <a:t>Juste quelques mois pour vérifier s'il tient debout.</a:t>
             </a:r>
             <a:endParaRPr lang="en-US" sz="1400" dirty="0"/>
           </a:p>
@@ -6257,7 +6719,7 @@
                 <a:ea typeface="Cambria" pitchFamily="34" charset="-122"/>
                 <a:cs typeface="Cambria" pitchFamily="34" charset="-120"/>
               </a:rPr>
-              <a:t>Du temps</a:t>
+              <a:t>Du temps — 3 à 6 mois</a:t>
             </a:r>
             <a:endParaRPr lang="en-US" sz="1900" dirty="0"/>
           </a:p>
@@ -6296,7 +6758,7 @@
                 <a:ea typeface="Calibri" pitchFamily="34" charset="-122"/>
                 <a:cs typeface="Calibri" pitchFamily="34" charset="-120"/>
               </a:rPr>
-              <a:t>~12 à 18 mois pour étudier et dé-risquer le projet, avant toute vente.</a:t>
+              <a:t>Le temps de vérifier qu'il existe vraiment un acheteur. Pas plus, pour commencer.</a:t>
             </a:r>
             <a:endParaRPr lang="en-US" sz="1450" dirty="0"/>
           </a:p>
@@ -6421,7 +6883,7 @@
                 <a:ea typeface="Cambria" pitchFamily="34" charset="-122"/>
                 <a:cs typeface="Cambria" pitchFamily="34" charset="-120"/>
               </a:rPr>
-              <a:t>Une exclusivité</a:t>
+              <a:t>Une exclusivité courte</a:t>
             </a:r>
             <a:endParaRPr lang="en-US" sz="1900" dirty="0"/>
           </a:p>
@@ -6624,7 +7086,7 @@
                 <a:ea typeface="Calibri" pitchFamily="34" charset="-122"/>
                 <a:cs typeface="Calibri" pitchFamily="34" charset="-120"/>
               </a:rPr>
-              <a:t>On avance ensemble, en transparence. Je te rends compte à chaque étape.</a:t>
+              <a:t>On avance ensemble, en transparence. On refait le point avec les réponses en main.</a:t>
             </a:r>
             <a:endParaRPr lang="en-US" sz="1450" dirty="0"/>
           </a:p>
@@ -7593,7 +8055,7 @@
                 <a:ea typeface="Calibri" pitchFamily="34" charset="-122"/>
                 <a:cs typeface="Calibri" pitchFamily="34" charset="-120"/>
               </a:rPr>
-              <a:t>annoncés en France pour les data centers (IA, cloud)</a:t>
+              <a:t>annoncés en France pour les data centers d'ici 2030</a:t>
             </a:r>
             <a:endParaRPr lang="en-US" sz="1300" dirty="0"/>
           </a:p>
@@ -7693,7 +8155,7 @@
                 <a:ea typeface="Calibri" pitchFamily="34" charset="-122"/>
                 <a:cs typeface="Calibri" pitchFamily="34" charset="-120"/>
               </a:rPr>
-              <a:t>de délai pour un raccordement électrique — le vrai goulot</a:t>
+              <a:t>de délai pour obtenir un raccordement électrique aujourd'hui</a:t>
             </a:r>
             <a:endParaRPr lang="en-US" sz="1300" dirty="0"/>
           </a:p>
@@ -7754,7 +8216,7 @@
                 <a:ea typeface="Cambria" pitchFamily="34" charset="-122"/>
                 <a:cs typeface="Cambria" pitchFamily="34" charset="-120"/>
               </a:rPr>
-              <a:t>× 2 à 4</a:t>
+              <a:t>N°1</a:t>
             </a:r>
             <a:endParaRPr lang="en-US" sz="3400" dirty="0"/>
           </a:p>
@@ -7793,7 +8255,7 @@
                 <a:ea typeface="Calibri" pitchFamily="34" charset="-122"/>
                 <a:cs typeface="Calibri" pitchFamily="34" charset="-120"/>
               </a:rPr>
-              <a:t>la valeur d'un terrain avec puissance sécurisée (Europe)</a:t>
+              <a:t>la puissance disponible est devenue le premier critère de choix d'un site</a:t>
             </a:r>
             <a:endParaRPr lang="en-US" sz="1300" dirty="0"/>
           </a:p>
@@ -7859,7 +8321,7 @@
                 <a:ea typeface="Cambria" pitchFamily="34" charset="-122"/>
                 <a:cs typeface="Cambria" pitchFamily="34" charset="-120"/>
               </a:rPr>
-              <a:t>Des acteurs majeurs font déjà exactement ça</a:t>
+              <a:t>Ce métier existe déjà en France — je ne l'invente pas</a:t>
             </a:r>
             <a:endParaRPr lang="en-US" sz="1700" dirty="0"/>
           </a:p>
@@ -7874,7 +8336,7 @@
         <p:spPr>
           <a:xfrm>
             <a:off x="914400" y="4937760"/>
-            <a:ext cx="10332720" cy="1005840"/>
+            <a:ext cx="10332720" cy="1051560"/>
           </a:xfrm>
           <a:prstGeom prst="rect">
             <a:avLst/>
@@ -7894,7 +8356,7 @@
               <a:buChar char="•"/>
             </a:pPr>
             <a:r>
-              <a:rPr lang="en-US" sz="1450" dirty="0">
+              <a:rPr lang="en-US" sz="1400" dirty="0">
                 <a:solidFill>
                   <a:srgbClr val="1A2A31"/>
                 </a:solidFill>
@@ -7902,9 +8364,9 @@
                 <a:ea typeface="Calibri" pitchFamily="34" charset="-122"/>
                 <a:cs typeface="Calibri" pitchFamily="34" charset="-120"/>
               </a:rPr>
-              <a:t>EDF ouvre ses anciens sites industriels aux data centers pour leur raccordement déjà en place.</a:t>
-            </a:r>
-            <a:endParaRPr lang="en-US" sz="1450" dirty="0"/>
+              <a:t>Hadès Patrimoine (Paris) a fait métier de préparer des terrains « prêts à bâtir » pour data centers : permis, autorisations, poste électrique.</a:t>
+            </a:r>
+            <a:endParaRPr lang="en-US" sz="1400" dirty="0"/>
           </a:p>
           <a:p>
             <a:pPr marL="342900" indent="-342900">
@@ -7915,7 +8377,7 @@
               <a:buChar char="•"/>
             </a:pPr>
             <a:r>
-              <a:rPr lang="en-US" sz="1450" dirty="0">
+              <a:rPr lang="en-US" sz="1400" dirty="0">
                 <a:solidFill>
                   <a:srgbClr val="1A2A31"/>
                 </a:solidFill>
@@ -7923,9 +8385,9 @@
                 <a:ea typeface="Calibri" pitchFamily="34" charset="-122"/>
                 <a:cs typeface="Calibri" pitchFamily="34" charset="-120"/>
               </a:rPr>
-              <a:t>Altarea (promoteur) valorise près de Bordeaux un terrain avec 400 MW sécurisés, apporté à un exploitant.</a:t>
-            </a:r>
-            <a:endParaRPr lang="en-US" sz="1450" dirty="0"/>
+              <a:t>EDF ouvre ses anciens sites industriels ; l'État a identifié 35 terrains « clés en main » pour accueillir ces projets.</a:t>
+            </a:r>
+            <a:endParaRPr lang="en-US" sz="1400" dirty="0"/>
           </a:p>
         </p:txBody>
       </p:sp>
@@ -10520,7 +10982,7 @@
                 <a:ea typeface="Cambria" pitchFamily="34" charset="-122"/>
                 <a:cs typeface="Cambria" pitchFamily="34" charset="-120"/>
               </a:rPr>
-              <a:t>Dé-risquer d'abord, décider ensuite</a:t>
+              <a:t>Vérifier d'abord, investir ensuite, décider en dernier</a:t>
             </a:r>
             <a:endParaRPr lang="en-US" sz="3200" dirty="0"/>
           </a:p>
@@ -10556,8 +11018,8 @@
         </p:nvSpPr>
         <p:spPr>
           <a:xfrm>
-            <a:off x="914400" y="2286000"/>
-            <a:ext cx="4297680" cy="457200"/>
+            <a:off x="914400" y="2240280"/>
+            <a:ext cx="4389120" cy="457200"/>
           </a:xfrm>
           <a:prstGeom prst="rect">
             <a:avLst/>
@@ -10573,7 +11035,7 @@
               <a:buNone/>
             </a:pPr>
             <a:r>
-              <a:rPr lang="en-US" sz="1300" b="1" spc="100" kern="0" dirty="0">
+              <a:rPr lang="en-US" sz="1250" b="1" spc="100" kern="0" dirty="0">
                 <a:solidFill>
                   <a:srgbClr val="00A19A"/>
                 </a:solidFill>
@@ -10581,9 +11043,9 @@
                 <a:ea typeface="Calibri" pitchFamily="34" charset="-122"/>
                 <a:cs typeface="Calibri" pitchFamily="34" charset="-120"/>
               </a:rPr>
-              <a:t>PHASE 1 — DÉ-RISQUER  (~12-18 mois)</a:t>
-            </a:r>
-            <a:endParaRPr lang="en-US" sz="1300" dirty="0"/>
+              <a:t>ÉTAPE 1 — VÉRIFIER  (3-6 mois, sans dépense)</a:t>
+            </a:r>
+            <a:endParaRPr lang="en-US" sz="1250" dirty="0"/>
           </a:p>
         </p:txBody>
       </p:sp>
@@ -10595,8 +11057,8 @@
         </p:nvSpPr>
         <p:spPr>
           <a:xfrm>
-            <a:off x="914400" y="2880360"/>
-            <a:ext cx="4389120" cy="2926080"/>
+            <a:off x="914400" y="2743200"/>
+            <a:ext cx="4389120" cy="1188720"/>
           </a:xfrm>
           <a:prstGeom prst="rect">
             <a:avLst/>
@@ -10610,13 +11072,13 @@
           <a:p>
             <a:pPr marL="342900" indent="-342900">
               <a:spcAft>
-                <a:spcPts val="1200"/>
+                <a:spcPts val="1000"/>
               </a:spcAft>
               <a:buSzPct val="100000"/>
               <a:buChar char="•"/>
             </a:pPr>
             <a:r>
-              <a:rPr lang="en-US" sz="1450" dirty="0">
+              <a:rPr lang="en-US" sz="1400" dirty="0">
                 <a:solidFill>
                   <a:srgbClr val="E6EFF0"/>
                 </a:solidFill>
@@ -10624,20 +11086,20 @@
                 <a:ea typeface="Calibri" pitchFamily="34" charset="-122"/>
                 <a:cs typeface="Calibri" pitchFamily="34" charset="-120"/>
               </a:rPr>
-              <a:t>Électricité : pré-étude puis réservation de la puissance (Enedis)</a:t>
-            </a:r>
-            <a:endParaRPr lang="en-US" sz="1450" dirty="0"/>
+              <a:t>Contacter les spécialistes du foncier data center</a:t>
+            </a:r>
+            <a:endParaRPr lang="en-US" sz="1400" dirty="0"/>
           </a:p>
           <a:p>
             <a:pPr marL="342900" indent="-342900">
               <a:spcAft>
-                <a:spcPts val="1200"/>
+                <a:spcPts val="1000"/>
               </a:spcAft>
               <a:buSzPct val="100000"/>
               <a:buChar char="•"/>
             </a:pPr>
             <a:r>
-              <a:rPr lang="en-US" sz="1450" dirty="0">
+              <a:rPr lang="en-US" sz="1400" dirty="0">
                 <a:solidFill>
                   <a:srgbClr val="E6EFF0"/>
                 </a:solidFill>
@@ -10645,20 +11107,81 @@
                 <a:ea typeface="Calibri" pitchFamily="34" charset="-122"/>
                 <a:cs typeface="Calibri" pitchFamily="34" charset="-120"/>
               </a:rPr>
-              <a:t>Urbanisme : certificat d'urbanisme + discussion avec la mairie</a:t>
-            </a:r>
-            <a:endParaRPr lang="en-US" sz="1450" dirty="0"/>
-          </a:p>
+              <a:t>Sonder les opérateurs : ce site les intéresse-t-il ?</a:t>
+            </a:r>
+            <a:endParaRPr lang="en-US" sz="1400" dirty="0"/>
+          </a:p>
+        </p:txBody>
+      </p:sp>
+      <p:sp>
+        <p:nvSpPr>
+          <p:cNvPr id="7" name="Text 5"/>
+          <p:cNvSpPr/>
+          <p:nvPr/>
+        </p:nvSpPr>
+        <p:spPr>
+          <a:xfrm>
+            <a:off x="914400" y="3977640"/>
+            <a:ext cx="4389120" cy="457200"/>
+          </a:xfrm>
+          <a:prstGeom prst="rect">
+            <a:avLst/>
+          </a:prstGeom>
+          <a:noFill/>
+          <a:ln/>
+        </p:spPr>
+        <p:txBody>
+          <a:bodyPr wrap="square" rtlCol="0" anchor="ctr"/>
+          <a:lstStyle/>
+          <a:p>
+            <a:pPr indent="0" marL="0">
+              <a:buNone/>
+            </a:pPr>
+            <a:r>
+              <a:rPr lang="en-US" sz="1250" b="1" spc="100" kern="0" dirty="0">
+                <a:solidFill>
+                  <a:srgbClr val="00A19A"/>
+                </a:solidFill>
+                <a:latin typeface="Calibri" pitchFamily="34" charset="0"/>
+                <a:ea typeface="Calibri" pitchFamily="34" charset="-122"/>
+                <a:cs typeface="Calibri" pitchFamily="34" charset="-120"/>
+              </a:rPr>
+              <a:t>ÉTAPE 2 — SÉCURISER  (si l'étape 1 est positive)</a:t>
+            </a:r>
+            <a:endParaRPr lang="en-US" sz="1250" dirty="0"/>
+          </a:p>
+        </p:txBody>
+      </p:sp>
+      <p:sp>
+        <p:nvSpPr>
+          <p:cNvPr id="8" name="Text 6"/>
+          <p:cNvSpPr/>
+          <p:nvPr/>
+        </p:nvSpPr>
+        <p:spPr>
+          <a:xfrm>
+            <a:off x="914400" y="4480560"/>
+            <a:ext cx="4389120" cy="1463040"/>
+          </a:xfrm>
+          <a:prstGeom prst="rect">
+            <a:avLst/>
+          </a:prstGeom>
+          <a:noFill/>
+          <a:ln/>
+        </p:spPr>
+        <p:txBody>
+          <a:bodyPr wrap="square" rtlCol="0" anchor="ctr"/>
+          <a:lstStyle/>
           <a:p>
             <a:pPr marL="342900" indent="-342900">
               <a:spcAft>
-                <a:spcPts val="1200"/>
+                <a:spcPts val="800"/>
               </a:spcAft>
               <a:buSzPct val="100000"/>
               <a:buChar char="•"/>
             </a:pPr>
             <a:r>
-              <a:rPr lang="en-US" sz="1450" dirty="0">
+              <a:rPr lang="en-US" sz="1400" dirty="0">
                 <a:solidFill>
                   <a:srgbClr val="E6EFF0"/>
                 </a:solidFill>
@@ -10666,20 +11189,20 @@
                 <a:ea typeface="Calibri" pitchFamily="34" charset="-122"/>
                 <a:cs typeface="Calibri" pitchFamily="34" charset="-120"/>
               </a:rPr>
-              <a:t>Fibre : confirmer les offres opérateurs</a:t>
-            </a:r>
-            <a:endParaRPr lang="en-US" sz="1450" dirty="0"/>
+              <a:t>Réserver la puissance électrique auprès d'Enedis</a:t>
+            </a:r>
+            <a:endParaRPr lang="en-US" sz="1400" dirty="0"/>
           </a:p>
           <a:p>
             <a:pPr marL="342900" indent="-342900">
               <a:spcAft>
-                <a:spcPts val="1200"/>
+                <a:spcPts val="800"/>
               </a:spcAft>
               <a:buSzPct val="100000"/>
               <a:buChar char="•"/>
             </a:pPr>
             <a:r>
-              <a:rPr lang="en-US" sz="1450" dirty="0">
+              <a:rPr lang="en-US" sz="1400" dirty="0">
                 <a:solidFill>
                   <a:srgbClr val="E6EFF0"/>
                 </a:solidFill>
@@ -10687,85 +11210,106 @@
                 <a:ea typeface="Calibri" pitchFamily="34" charset="-122"/>
                 <a:cs typeface="Calibri" pitchFamily="34" charset="-120"/>
               </a:rPr>
-              <a:t>Sonder les acheteurs / exploitants possibles</a:t>
-            </a:r>
-            <a:endParaRPr lang="en-US" sz="1450" dirty="0"/>
-          </a:p>
-        </p:txBody>
-      </p:sp>
-      <p:sp>
-        <p:nvSpPr>
-          <p:cNvPr id="7" name="Text 5"/>
-          <p:cNvSpPr/>
-          <p:nvPr/>
-        </p:nvSpPr>
-        <p:spPr>
-          <a:xfrm>
-            <a:off x="5532120" y="3657600"/>
-            <a:ext cx="640080" cy="731520"/>
-          </a:xfrm>
-          <a:prstGeom prst="rect">
-            <a:avLst/>
-          </a:prstGeom>
-          <a:noFill/>
-          <a:ln/>
-        </p:spPr>
-        <p:txBody>
-          <a:bodyPr wrap="square" rtlCol="0" anchor="ctr"/>
-          <a:lstStyle/>
-          <a:p>
-            <a:pPr algn="ctr" indent="0" marL="0">
-              <a:buNone/>
-            </a:pPr>
-            <a:r>
-              <a:rPr lang="en-US" sz="3400" b="1" dirty="0">
-                <a:solidFill>
-                  <a:srgbClr val="00A19A"/>
+              <a:t>Obtenir le permis avec la mairie de Rodez</a:t>
+            </a:r>
+            <a:endParaRPr lang="en-US" sz="1400" dirty="0"/>
+          </a:p>
+          <a:p>
+            <a:pPr marL="342900" indent="-342900">
+              <a:spcAft>
+                <a:spcPts val="800"/>
+              </a:spcAft>
+              <a:buSzPct val="100000"/>
+              <a:buChar char="•"/>
+            </a:pPr>
+            <a:r>
+              <a:rPr lang="en-US" sz="1400" dirty="0">
+                <a:solidFill>
+                  <a:srgbClr val="E6EFF0"/>
                 </a:solidFill>
                 <a:latin typeface="Calibri" pitchFamily="34" charset="0"/>
                 <a:ea typeface="Calibri" pitchFamily="34" charset="-122"/>
                 <a:cs typeface="Calibri" pitchFamily="34" charset="-120"/>
               </a:rPr>
-              <a:t>→</a:t>
-            </a:r>
-            <a:endParaRPr lang="en-US" sz="3400" dirty="0"/>
-          </a:p>
-        </p:txBody>
-      </p:sp>
-      <p:sp>
-        <p:nvSpPr>
-          <p:cNvPr id="8" name="Text 6"/>
-          <p:cNvSpPr/>
-          <p:nvPr/>
-        </p:nvSpPr>
-        <p:spPr>
-          <a:xfrm>
-            <a:off x="6217920" y="2103120"/>
-            <a:ext cx="5303520" cy="365760"/>
-          </a:xfrm>
-          <a:prstGeom prst="rect">
-            <a:avLst/>
-          </a:prstGeom>
-          <a:noFill/>
-          <a:ln/>
-        </p:spPr>
-        <p:txBody>
-          <a:bodyPr wrap="square" rtlCol="0" anchor="ctr"/>
-          <a:lstStyle/>
-          <a:p>
-            <a:pPr indent="0" marL="0">
-              <a:buNone/>
-            </a:pPr>
-            <a:r>
-              <a:rPr lang="en-US" sz="1300" b="1" spc="100" kern="0" dirty="0">
-                <a:solidFill>
-                  <a:srgbClr val="EC5F65"/>
+              <a:t>Traiter l'amiante et démolir</a:t>
+            </a:r>
+            <a:endParaRPr lang="en-US" sz="1400" dirty="0"/>
+          </a:p>
+        </p:txBody>
+      </p:sp>
+      <p:sp>
+        <p:nvSpPr>
+          <p:cNvPr id="9" name="Text 7"/>
+          <p:cNvSpPr/>
+          <p:nvPr/>
+        </p:nvSpPr>
+        <p:spPr>
+          <a:xfrm>
+            <a:off x="5532120" y="3657600"/>
+            <a:ext cx="640080" cy="731520"/>
+          </a:xfrm>
+          <a:prstGeom prst="rect">
+            <a:avLst/>
+          </a:prstGeom>
+          <a:noFill/>
+          <a:ln/>
+        </p:spPr>
+        <p:txBody>
+          <a:bodyPr wrap="square" rtlCol="0" anchor="ctr"/>
+          <a:lstStyle/>
+          <a:p>
+            <a:pPr algn="ctr" indent="0" marL="0">
+              <a:buNone/>
+            </a:pPr>
+            <a:r>
+              <a:rPr lang="en-US" sz="3400" b="1" dirty="0">
+                <a:solidFill>
+                  <a:srgbClr val="00A19A"/>
                 </a:solidFill>
                 <a:latin typeface="Calibri" pitchFamily="34" charset="0"/>
                 <a:ea typeface="Calibri" pitchFamily="34" charset="-122"/>
                 <a:cs typeface="Calibri" pitchFamily="34" charset="-120"/>
               </a:rPr>
-              <a:t>PHASE 2 — TU CHOISIS</a:t>
+              <a:t>→</a:t>
+            </a:r>
+            <a:endParaRPr lang="en-US" sz="3400" dirty="0"/>
+          </a:p>
+        </p:txBody>
+      </p:sp>
+      <p:sp>
+        <p:nvSpPr>
+          <p:cNvPr id="10" name="Text 8"/>
+          <p:cNvSpPr/>
+          <p:nvPr/>
+        </p:nvSpPr>
+        <p:spPr>
+          <a:xfrm>
+            <a:off x="6217920" y="2103120"/>
+            <a:ext cx="5303520" cy="365760"/>
+          </a:xfrm>
+          <a:prstGeom prst="rect">
+            <a:avLst/>
+          </a:prstGeom>
+          <a:noFill/>
+          <a:ln/>
+        </p:spPr>
+        <p:txBody>
+          <a:bodyPr wrap="square" rtlCol="0" anchor="ctr"/>
+          <a:lstStyle/>
+          <a:p>
+            <a:pPr indent="0" marL="0">
+              <a:buNone/>
+            </a:pPr>
+            <a:r>
+              <a:rPr lang="en-US" sz="1300" b="1" spc="100" kern="0" dirty="0">
+                <a:solidFill>
+                  <a:srgbClr val="EC5F65"/>
+                </a:solidFill>
+                <a:latin typeface="Calibri" pitchFamily="34" charset="0"/>
+                <a:ea typeface="Calibri" pitchFamily="34" charset="-122"/>
+                <a:cs typeface="Calibri" pitchFamily="34" charset="-120"/>
+              </a:rPr>
+              <a:t>ÉTAPE 3 — TU CHOISIS</a:t>
             </a:r>
             <a:endParaRPr lang="en-US" sz="1300" dirty="0"/>
           </a:p>
@@ -10773,7 +11317,7 @@
       </p:sp>
       <p:sp>
         <p:nvSpPr>
-          <p:cNvPr id="9" name="Shape 7"/>
+          <p:cNvPr id="11" name="Shape 9"/>
           <p:cNvSpPr/>
           <p:nvPr/>
         </p:nvSpPr>
@@ -10800,7 +11344,7 @@
       </p:sp>
       <p:sp>
         <p:nvSpPr>
-          <p:cNvPr id="10" name="Shape 8"/>
+          <p:cNvPr id="12" name="Shape 10"/>
           <p:cNvSpPr/>
           <p:nvPr/>
         </p:nvSpPr>
@@ -10820,7 +11364,7 @@
       </p:sp>
       <p:sp>
         <p:nvSpPr>
-          <p:cNvPr id="11" name="Text 9"/>
+          <p:cNvPr id="13" name="Text 11"/>
           <p:cNvSpPr/>
           <p:nvPr/>
         </p:nvSpPr>
@@ -10859,7 +11403,7 @@
       </p:sp>
       <p:sp>
         <p:nvSpPr>
-          <p:cNvPr id="12" name="Text 10"/>
+          <p:cNvPr id="14" name="Text 12"/>
           <p:cNvSpPr/>
           <p:nvPr/>
         </p:nvSpPr>
@@ -10898,7 +11442,7 @@
       </p:sp>
       <p:sp>
         <p:nvSpPr>
-          <p:cNvPr id="13" name="Text 11"/>
+          <p:cNvPr id="15" name="Text 13"/>
           <p:cNvSpPr/>
           <p:nvPr/>
         </p:nvSpPr>
@@ -10937,7 +11481,7 @@
       </p:sp>
       <p:sp>
         <p:nvSpPr>
-          <p:cNvPr id="14" name="Shape 12"/>
+          <p:cNvPr id="16" name="Shape 14"/>
           <p:cNvSpPr/>
           <p:nvPr/>
         </p:nvSpPr>
@@ -10964,7 +11508,7 @@
       </p:sp>
       <p:sp>
         <p:nvSpPr>
-          <p:cNvPr id="15" name="Shape 13"/>
+          <p:cNvPr id="17" name="Shape 15"/>
           <p:cNvSpPr/>
           <p:nvPr/>
         </p:nvSpPr>
@@ -10984,7 +11528,7 @@
       </p:sp>
       <p:sp>
         <p:nvSpPr>
-          <p:cNvPr id="16" name="Text 14"/>
+          <p:cNvPr id="18" name="Text 16"/>
           <p:cNvSpPr/>
           <p:nvPr/>
         </p:nvSpPr>
@@ -11023,7 +11567,7 @@
       </p:sp>
       <p:sp>
         <p:nvSpPr>
-          <p:cNvPr id="17" name="Text 15"/>
+          <p:cNvPr id="19" name="Text 17"/>
           <p:cNvSpPr/>
           <p:nvPr/>
         </p:nvSpPr>
@@ -11062,7 +11606,7 @@
       </p:sp>
       <p:sp>
         <p:nvSpPr>
-          <p:cNvPr id="18" name="Text 16"/>
+          <p:cNvPr id="20" name="Text 18"/>
           <p:cNvSpPr/>
           <p:nvPr/>
         </p:nvSpPr>
@@ -11101,7 +11645,7 @@
       </p:sp>
       <p:sp>
         <p:nvSpPr>
-          <p:cNvPr id="19" name="Shape 17"/>
+          <p:cNvPr id="21" name="Shape 19"/>
           <p:cNvSpPr/>
           <p:nvPr/>
         </p:nvSpPr>
@@ -11128,7 +11672,7 @@
       </p:sp>
       <p:sp>
         <p:nvSpPr>
-          <p:cNvPr id="20" name="Shape 18"/>
+          <p:cNvPr id="22" name="Shape 20"/>
           <p:cNvSpPr/>
           <p:nvPr/>
         </p:nvSpPr>
@@ -11148,7 +11692,7 @@
       </p:sp>
       <p:sp>
         <p:nvSpPr>
-          <p:cNvPr id="21" name="Text 19"/>
+          <p:cNvPr id="23" name="Text 21"/>
           <p:cNvSpPr/>
           <p:nvPr/>
         </p:nvSpPr>
@@ -11187,7 +11731,7 @@
       </p:sp>
       <p:sp>
         <p:nvSpPr>
-          <p:cNvPr id="22" name="Text 20"/>
+          <p:cNvPr id="24" name="Text 22"/>
           <p:cNvSpPr/>
           <p:nvPr/>
         </p:nvSpPr>
@@ -11226,7 +11770,7 @@
       </p:sp>
       <p:sp>
         <p:nvSpPr>
-          <p:cNvPr id="23" name="Text 21"/>
+          <p:cNvPr id="25" name="Text 23"/>
           <p:cNvSpPr/>
           <p:nvPr/>
         </p:nvSpPr>
@@ -11265,7 +11809,7 @@
       </p:sp>
       <p:sp>
         <p:nvSpPr>
-          <p:cNvPr id="24" name="Text 22"/>
+          <p:cNvPr id="26" name="Text 24"/>
           <p:cNvSpPr/>
           <p:nvPr/>
         </p:nvSpPr>

</xml_diff>